<commit_message>
Slides: sd-10-027, 028 decks and PPTX follow the corrected lessons
Co-Authored-By: Claude Sonnet 5.5 <noreply@anthropic.com>
Claude-Session: https://claude.ai/code/session_01JJCRKgpbfdpiPMwgBVozBY
</commit_message>
<xml_diff>
--- a/system-design-101/vi/lessons/sd-10-027/slides/sd-10-027.pptx
+++ b/system-design-101/vi/lessons/sd-10-027/slides/sd-10-027.pptx
@@ -4190,6 +4190,28 @@
               <a:buNone/>
             </a:pPr>
             <a:r>
+              <a:rPr lang="en-US" sz="2100" dirty="0" spc="1" kern="0">
+                <a:solidFill>
+                  <a:srgbClr val="C4C8D6"/>
+                </a:solidFill>
+                <a:latin typeface="Be Vietnam Pro" pitchFamily="34" charset="0"/>
+                <a:ea typeface="Be Vietnam Pro" pitchFamily="34" charset="-122"/>
+                <a:cs typeface="Be Vietnam Pro" pitchFamily="34" charset="-120"/>
+              </a:rPr>
+              <a:t>Mang</a:t>
+            </a:r>
+            <a:r>
+              <a:rPr lang="en-US" sz="2100" dirty="0" spc="-1" kern="0">
+                <a:solidFill>
+                  <a:srgbClr val="C4C8D6"/>
+                </a:solidFill>
+                <a:latin typeface="Be Vietnam Pro" pitchFamily="34" charset="0"/>
+                <a:ea typeface="Be Vietnam Pro" pitchFamily="34" charset="-122"/>
+                <a:cs typeface="Be Vietnam Pro" pitchFamily="34" charset="-120"/>
+              </a:rPr>
+              <a:t> thông</a:t>
+            </a:r>
+            <a:r>
               <a:rPr lang="en-US" sz="2100" dirty="0" spc="0" kern="0">
                 <a:solidFill>
                   <a:srgbClr val="C4C8D6"/>
@@ -4198,7 +4220,51 @@
                 <a:ea typeface="Be Vietnam Pro" pitchFamily="34" charset="-122"/>
                 <a:cs typeface="Be Vietnam Pro" pitchFamily="34" charset="-120"/>
               </a:rPr>
-              <a:t>Chuỗi tự</a:t>
+              <a:t> tin</a:t>
+            </a:r>
+            <a:r>
+              <a:rPr lang="en-US" sz="2100" dirty="0" spc="-18" kern="0">
+                <a:solidFill>
+                  <a:srgbClr val="C4C8D6"/>
+                </a:solidFill>
+                <a:latin typeface="Be Vietnam Pro" pitchFamily="34" charset="0"/>
+                <a:ea typeface="Be Vietnam Pro" pitchFamily="34" charset="-122"/>
+                <a:cs typeface="Be Vietnam Pro" pitchFamily="34" charset="-120"/>
+              </a:rPr>
+              <a:t> xác</a:t>
+            </a:r>
+            <a:r>
+              <a:rPr lang="en-US" sz="2100" dirty="0" spc="0" kern="0">
+                <a:solidFill>
+                  <a:srgbClr val="C4C8D6"/>
+                </a:solidFill>
+                <a:latin typeface="Be Vietnam Pro" pitchFamily="34" charset="0"/>
+                <a:ea typeface="Be Vietnam Pro" pitchFamily="34" charset="-122"/>
+                <a:cs typeface="Be Vietnam Pro" pitchFamily="34" charset="-120"/>
+              </a:rPr>
+              <a:t> nhận,</a:t>
+            </a:r>
+            <a:r>
+              <a:rPr lang="en-US" sz="2100" dirty="0" spc="2" kern="0">
+                <a:solidFill>
+                  <a:srgbClr val="C4C8D6"/>
+                </a:solidFill>
+                <a:latin typeface="Be Vietnam Pro" pitchFamily="34" charset="0"/>
+                <a:ea typeface="Be Vietnam Pro" pitchFamily="34" charset="-122"/>
+                <a:cs typeface="Be Vietnam Pro" pitchFamily="34" charset="-120"/>
+              </a:rPr>
+              <a:t> thường</a:t>
+            </a:r>
+            <a:r>
+              <a:rPr lang="en-US" sz="2100" dirty="0" spc="-2" kern="0">
+                <a:solidFill>
+                  <a:srgbClr val="C4C8D6"/>
+                </a:solidFill>
+                <a:latin typeface="Be Vietnam Pro" pitchFamily="34" charset="0"/>
+                <a:ea typeface="Be Vietnam Pro" pitchFamily="34" charset="-122"/>
+                <a:cs typeface="Be Vietnam Pro" pitchFamily="34" charset="-120"/>
+              </a:rPr>
+              <a:t> có</a:t>
             </a:r>
             <a:r>
               <a:rPr lang="en-US" sz="2100" dirty="0" spc="-1" kern="0">
@@ -4209,10 +4275,10 @@
                 <a:ea typeface="Be Vietnam Pro" pitchFamily="34" charset="-122"/>
                 <a:cs typeface="Be Vietnam Pro" pitchFamily="34" charset="-120"/>
               </a:rPr>
-              <a:t> mang thông</a:t>
-            </a:r>
-            <a:r>
-              <a:rPr lang="en-US" sz="2100" dirty="0" spc="0" kern="0">
+              <a:t> chữ ký;</a:t>
+            </a:r>
+            <a:r>
+              <a:rPr lang="en-US" sz="2100" dirty="0" spc="-2" kern="0">
                 <a:solidFill>
                   <a:srgbClr val="C4C8D6"/>
                 </a:solidFill>
@@ -4220,10 +4286,10 @@
                 <a:ea typeface="Be Vietnam Pro" pitchFamily="34" charset="-122"/>
                 <a:cs typeface="Be Vietnam Pro" pitchFamily="34" charset="-120"/>
               </a:rPr>
-              <a:t> tin</a:t>
-            </a:r>
-            <a:r>
-              <a:rPr lang="en-US" sz="2100" dirty="0" spc="5" kern="0">
+              <a:t> phải</a:t>
+            </a:r>
+            <a:r>
+              <a:rPr lang="en-US" sz="2100" dirty="0" spc="2" kern="0">
                 <a:solidFill>
                   <a:srgbClr val="C4C8D6"/>
                 </a:solidFill>
@@ -4231,10 +4297,10 @@
                 <a:ea typeface="Be Vietnam Pro" pitchFamily="34" charset="-122"/>
                 <a:cs typeface="Be Vietnam Pro" pitchFamily="34" charset="-120"/>
               </a:rPr>
-              <a:t> người</a:t>
-            </a:r>
-            <a:r>
-              <a:rPr lang="en-US" sz="2100" dirty="0" spc="-1" kern="0">
+              <a:t> kiểm</a:t>
+            </a:r>
+            <a:r>
+              <a:rPr lang="en-US" sz="2100" dirty="0" spc="-19" kern="0">
                 <a:solidFill>
                   <a:srgbClr val="C4C8D6"/>
                 </a:solidFill>
@@ -4242,51 +4308,7 @@
                 <a:ea typeface="Be Vietnam Pro" pitchFamily="34" charset="-122"/>
                 <a:cs typeface="Be Vietnam Pro" pitchFamily="34" charset="-120"/>
               </a:rPr>
-              <a:t> dùng</a:t>
-            </a:r>
-            <a:r>
-              <a:rPr lang="en-US" sz="2100" dirty="0" spc="-18" kern="0">
-                <a:solidFill>
-                  <a:srgbClr val="C4C8D6"/>
-                </a:solidFill>
-                <a:latin typeface="Be Vietnam Pro" pitchFamily="34" charset="0"/>
-                <a:ea typeface="Be Vietnam Pro" pitchFamily="34" charset="-122"/>
-                <a:cs typeface="Be Vietnam Pro" pitchFamily="34" charset="-120"/>
-              </a:rPr>
-              <a:t> và</a:t>
-            </a:r>
-            <a:r>
-              <a:rPr lang="en-US" sz="2100" dirty="0" spc="-3" kern="0">
-                <a:solidFill>
-                  <a:srgbClr val="C4C8D6"/>
-                </a:solidFill>
-                <a:latin typeface="Be Vietnam Pro" pitchFamily="34" charset="0"/>
-                <a:ea typeface="Be Vietnam Pro" pitchFamily="34" charset="-122"/>
-                <a:cs typeface="Be Vietnam Pro" pitchFamily="34" charset="-120"/>
-              </a:rPr>
-              <a:t> có</a:t>
-            </a:r>
-            <a:r>
-              <a:rPr lang="en-US" sz="2100" dirty="0" spc="-1" kern="0">
-                <a:solidFill>
-                  <a:srgbClr val="C4C8D6"/>
-                </a:solidFill>
-                <a:latin typeface="Be Vietnam Pro" pitchFamily="34" charset="0"/>
-                <a:ea typeface="Be Vietnam Pro" pitchFamily="34" charset="-122"/>
-                <a:cs typeface="Be Vietnam Pro" pitchFamily="34" charset="-120"/>
-              </a:rPr>
-              <a:t> chữ</a:t>
-            </a:r>
-            <a:r>
-              <a:rPr lang="en-US" sz="2100" dirty="0" spc="0" kern="0">
-                <a:solidFill>
-                  <a:srgbClr val="C4C8D6"/>
-                </a:solidFill>
-                <a:latin typeface="Be Vietnam Pro" pitchFamily="34" charset="0"/>
-                <a:ea typeface="Be Vietnam Pro" pitchFamily="34" charset="-122"/>
-                <a:cs typeface="Be Vietnam Pro" pitchFamily="34" charset="-120"/>
-              </a:rPr>
-              <a:t> ký.</a:t>
+              <a:t> tra.</a:t>
             </a:r>
             <a:endParaRPr lang="en-US" sz="2100" dirty="0"/>
           </a:p>
@@ -11637,7 +11659,7 @@
               <a:t>OAuth2</a:t>
             </a:r>
             <a:r>
-              <a:rPr lang="en-US" sz="2100" b="1" dirty="0" spc="-13" kern="0">
+              <a:rPr lang="en-US" sz="2100" b="1" dirty="0" spc="-19" kern="0">
                 <a:solidFill>
                   <a:srgbClr val="B45309"/>
                 </a:solidFill>
@@ -11645,10 +11667,10 @@
                 <a:ea typeface="Be Vietnam Pro" pitchFamily="34" charset="-122"/>
                 <a:cs typeface="Be Vietnam Pro" pitchFamily="34" charset="-120"/>
               </a:rPr>
-              <a:t> với</a:t>
-            </a:r>
-            <a:r>
-              <a:rPr lang="en-US" sz="2100" b="1" dirty="0" spc="-21" kern="0">
+              <a:t> và</a:t>
+            </a:r>
+            <a:r>
+              <a:rPr lang="en-US" sz="2100" b="1" dirty="0" spc="-3" kern="0">
                 <a:solidFill>
                   <a:srgbClr val="B45309"/>
                 </a:solidFill>
@@ -11656,7 +11678,18 @@
                 <a:ea typeface="Be Vietnam Pro" pitchFamily="34" charset="-122"/>
                 <a:cs typeface="Be Vietnam Pro" pitchFamily="34" charset="-120"/>
               </a:rPr>
-              <a:t> PKCE;</a:t>
+              <a:t> OpenID</a:t>
+            </a:r>
+            <a:r>
+              <a:rPr lang="en-US" sz="2100" b="1" dirty="0" spc="-5" kern="0">
+                <a:solidFill>
+                  <a:srgbClr val="B45309"/>
+                </a:solidFill>
+                <a:latin typeface="Be Vietnam Pro" pitchFamily="34" charset="0"/>
+                <a:ea typeface="Be Vietnam Pro" pitchFamily="34" charset="-122"/>
+                <a:cs typeface="Be Vietnam Pro" pitchFamily="34" charset="-120"/>
+              </a:rPr>
+              <a:t> Connect;</a:t>
             </a:r>
             <a:r>
               <a:rPr lang="en-US" sz="2100" b="1" dirty="0" spc="-7" kern="0">

</xml_diff>